<commit_message>
docs: deck v3 reordered story (market, structure paths, alternatives matrix); alternative 2 with +2 seniors and +1 plenos
Co-Authored-By: Claude Fable 5.1 <noreply@anthropic.com>
Claude-Session: https://claude.ai/code/session_01EdiFW99rh4cyUjRbojqkjk
</commit_message>
<xml_diff>
--- a/docs/benchmarking/presentacion-reportes-normativos-v3.pptx
+++ b/docs/benchmarking/presentacion-reportes-normativos-v3.pptx
@@ -603,7 +603,7 @@
           <a:p>
             <a:r>
               <a:rPr lang="en-US" dirty="0"/>
-              <a:t>Presentar las alternativas con neutralidad y dejar que el comité pregunte. La 1 es simple y equitativa y reconoce a todo el equipo; la 2 diferencia responsabilidades, alinea grado con complejidad y crea una ruta de desarrollo, a cambio de definir criterios de selección transparentes. Son combinables: la 2 ahora y revisión de los plenos con la evaluación.</a:t>
+              <a:t>Presentar las alternativas con neutralidad y dejar que el comité pregunte. La 1 es simple y equitativa y reconoce a todo el equipo; la 2 también sube un grado a todos y, además, diferencia responsabilidades con dos seniors dos grados más, alineando grado con complejidad y creando una ruta de desarrollo, a cambio de definir criterios de selección transparentes.</a:t>
             </a:r>
             <a:endParaRPr lang="en-US" dirty="0"/>
           </a:p>
@@ -1659,7 +1659,7 @@
           <a:p>
             <a:r>
               <a:rPr lang="en-US" dirty="0"/>
-              <a:t>Leer de izquierda a derecha: hoy, seis cargos con el mismo grado administran reportes de complejidad muy distinta. Los dos caminos parten del mismo diagnóstico. El primero reconoce a todo el equipo y mantiene la estructura; el segundo diferencia roles y crea una ruta de desarrollo. La lámina siguiente los compara criterio a criterio.</a:t>
+              <a:t>Leer de izquierda a derecha: hoy, seis cargos con el mismo grado administran reportes de complejidad muy distinta. Los dos caminos parten del mismo diagnóstico. El primero reconoce a todo el equipo con un grado más y mantiene la estructura; el segundo también sube un grado a todos y diferencia roles con dos seniors dos grados más, creando una ruta de desarrollo. La lámina siguiente los compara criterio a criterio.</a:t>
             </a:r>
             <a:endParaRPr lang="en-US" dirty="0"/>
           </a:p>
@@ -2900,7 +2900,7 @@
                 <a:ea typeface="Calibri" pitchFamily="34" charset="-122"/>
                 <a:cs typeface="Calibri" pitchFamily="34" charset="-120"/>
               </a:rPr>
-              <a:t>Se alinea en los dos cargos que asumen los bloques críticos</a:t>
+              <a:t>Se alinea para todo el equipo, con mayor reconocimiento en los dos cargos que asumen los bloques críticos</a:t>
             </a:r>
             <a:endParaRPr lang="en-US" sz="1050" dirty="0"/>
           </a:p>
@@ -3003,7 +3003,7 @@
                 <a:ea typeface="Calibri" pitchFamily="34" charset="-122"/>
                 <a:cs typeface="Calibri" pitchFamily="34" charset="-120"/>
               </a:rPr>
-              <a:t>Plana: seis especialistas con el mismo grado</a:t>
+              <a:t>Plana: seis especialistas con el mismo grado, un nivel más</a:t>
             </a:r>
             <a:endParaRPr lang="en-US" sz="1050" dirty="0"/>
           </a:p>
@@ -3042,7 +3042,7 @@
                 <a:ea typeface="Calibri" pitchFamily="34" charset="-122"/>
                 <a:cs typeface="Calibri" pitchFamily="34" charset="-120"/>
               </a:rPr>
-              <a:t>Diferenciada: dos seniors y cuatro plenos</a:t>
+              <a:t>Diferenciada: dos seniors dos niveles más y cuatro plenos un nivel más</a:t>
             </a:r>
             <a:endParaRPr lang="en-US" sz="1050" dirty="0"/>
           </a:p>
@@ -3521,7 +3521,7 @@
                 <a:ea typeface="Calibri" pitchFamily="34" charset="-122"/>
                 <a:cs typeface="Calibri" pitchFamily="34" charset="-120"/>
               </a:rPr>
-              <a:t>Seis cargos</a:t>
+              <a:t>Seis cargos, un grado cada uno</a:t>
             </a:r>
             <a:endParaRPr lang="en-US" sz="1050" dirty="0"/>
           </a:p>
@@ -3560,7 +3560,7 @@
                 <a:ea typeface="Calibri" pitchFamily="34" charset="-122"/>
                 <a:cs typeface="Calibri" pitchFamily="34" charset="-120"/>
               </a:rPr>
-              <a:t>Dos cargos</a:t>
+              <a:t>Seis cargos: dos suben dos grados y cuatro suben uno</a:t>
             </a:r>
             <a:endParaRPr lang="en-US" sz="1050" dirty="0"/>
           </a:p>
@@ -26708,7 +26708,7 @@
                 <a:ea typeface="Calibri" pitchFamily="34" charset="-122"/>
                 <a:cs typeface="Calibri" pitchFamily="34" charset="-120"/>
               </a:rPr>
-              <a:t>+1</a:t>
+              <a:t>+2</a:t>
             </a:r>
             <a:endParaRPr lang="en-US" sz="800" dirty="0"/>
           </a:p>
@@ -26855,7 +26855,7 @@
                 <a:ea typeface="Calibri" pitchFamily="34" charset="-122"/>
                 <a:cs typeface="Calibri" pitchFamily="34" charset="-120"/>
               </a:rPr>
-              <a:t>+1</a:t>
+              <a:t>+2</a:t>
             </a:r>
             <a:endParaRPr lang="en-US" sz="800" dirty="0"/>
           </a:p>
@@ -27242,7 +27242,263 @@
       </p:sp>
       <p:sp>
         <p:nvSpPr>
-          <p:cNvPr id="109" name="Text 107"/>
+          <p:cNvPr id="109" name="Shape 107"/>
+          <p:cNvSpPr/>
+          <p:nvPr/>
+        </p:nvSpPr>
+        <p:spPr>
+          <a:xfrm>
+            <a:off x="8868156" y="4297680"/>
+            <a:ext cx="274320" cy="274320"/>
+          </a:xfrm>
+          <a:prstGeom prst="ellipse">
+            <a:avLst/>
+          </a:prstGeom>
+          <a:solidFill>
+            <a:srgbClr val="6A9B6E"/>
+          </a:solidFill>
+          <a:ln w="12700">
+            <a:solidFill>
+              <a:srgbClr val="FFFFFF"/>
+            </a:solidFill>
+            <a:prstDash val="solid"/>
+          </a:ln>
+        </p:spPr>
+      </p:sp>
+      <p:sp>
+        <p:nvSpPr>
+          <p:cNvPr id="110" name="Text 108"/>
+          <p:cNvSpPr txBox="1"/>
+          <p:nvPr/>
+        </p:nvSpPr>
+        <p:spPr>
+          <a:xfrm>
+            <a:off x="8868156" y="4297680"/>
+            <a:ext cx="274320" cy="274320"/>
+          </a:xfrm>
+          <a:prstGeom prst="rect">
+            <a:avLst/>
+          </a:prstGeom>
+          <a:noFill/>
+          <a:ln/>
+        </p:spPr>
+        <p:txBody>
+          <a:bodyPr wrap="square" lIns="0" tIns="0" rIns="0" bIns="0" rtlCol="0" anchor="ctr"/>
+          <a:lstStyle/>
+          <a:p>
+            <a:pPr algn="ctr" indent="0" marL="0">
+              <a:buNone/>
+            </a:pPr>
+            <a:r>
+              <a:rPr lang="en-US" sz="800" b="1" dirty="0">
+                <a:solidFill>
+                  <a:srgbClr val="FFFFFF"/>
+                </a:solidFill>
+                <a:latin typeface="Calibri" pitchFamily="34" charset="0"/>
+                <a:ea typeface="Calibri" pitchFamily="34" charset="-122"/>
+                <a:cs typeface="Calibri" pitchFamily="34" charset="-120"/>
+              </a:rPr>
+              <a:t>+1</a:t>
+            </a:r>
+            <a:endParaRPr lang="en-US" sz="800" dirty="0"/>
+          </a:p>
+        </p:txBody>
+      </p:sp>
+      <p:sp>
+        <p:nvSpPr>
+          <p:cNvPr id="111" name="Shape 109"/>
+          <p:cNvSpPr/>
+          <p:nvPr/>
+        </p:nvSpPr>
+        <p:spPr>
+          <a:xfrm>
+            <a:off x="9672828" y="4297680"/>
+            <a:ext cx="274320" cy="274320"/>
+          </a:xfrm>
+          <a:prstGeom prst="ellipse">
+            <a:avLst/>
+          </a:prstGeom>
+          <a:solidFill>
+            <a:srgbClr val="6A9B6E"/>
+          </a:solidFill>
+          <a:ln w="12700">
+            <a:solidFill>
+              <a:srgbClr val="FFFFFF"/>
+            </a:solidFill>
+            <a:prstDash val="solid"/>
+          </a:ln>
+        </p:spPr>
+      </p:sp>
+      <p:sp>
+        <p:nvSpPr>
+          <p:cNvPr id="112" name="Text 110"/>
+          <p:cNvSpPr txBox="1"/>
+          <p:nvPr/>
+        </p:nvSpPr>
+        <p:spPr>
+          <a:xfrm>
+            <a:off x="9672828" y="4297680"/>
+            <a:ext cx="274320" cy="274320"/>
+          </a:xfrm>
+          <a:prstGeom prst="rect">
+            <a:avLst/>
+          </a:prstGeom>
+          <a:noFill/>
+          <a:ln/>
+        </p:spPr>
+        <p:txBody>
+          <a:bodyPr wrap="square" lIns="0" tIns="0" rIns="0" bIns="0" rtlCol="0" anchor="ctr"/>
+          <a:lstStyle/>
+          <a:p>
+            <a:pPr algn="ctr" indent="0" marL="0">
+              <a:buNone/>
+            </a:pPr>
+            <a:r>
+              <a:rPr lang="en-US" sz="800" b="1" dirty="0">
+                <a:solidFill>
+                  <a:srgbClr val="FFFFFF"/>
+                </a:solidFill>
+                <a:latin typeface="Calibri" pitchFamily="34" charset="0"/>
+                <a:ea typeface="Calibri" pitchFamily="34" charset="-122"/>
+                <a:cs typeface="Calibri" pitchFamily="34" charset="-120"/>
+              </a:rPr>
+              <a:t>+1</a:t>
+            </a:r>
+            <a:endParaRPr lang="en-US" sz="800" dirty="0"/>
+          </a:p>
+        </p:txBody>
+      </p:sp>
+      <p:sp>
+        <p:nvSpPr>
+          <p:cNvPr id="113" name="Shape 111"/>
+          <p:cNvSpPr/>
+          <p:nvPr/>
+        </p:nvSpPr>
+        <p:spPr>
+          <a:xfrm>
+            <a:off x="10477500" y="4297680"/>
+            <a:ext cx="274320" cy="274320"/>
+          </a:xfrm>
+          <a:prstGeom prst="ellipse">
+            <a:avLst/>
+          </a:prstGeom>
+          <a:solidFill>
+            <a:srgbClr val="6A9B6E"/>
+          </a:solidFill>
+          <a:ln w="12700">
+            <a:solidFill>
+              <a:srgbClr val="FFFFFF"/>
+            </a:solidFill>
+            <a:prstDash val="solid"/>
+          </a:ln>
+        </p:spPr>
+      </p:sp>
+      <p:sp>
+        <p:nvSpPr>
+          <p:cNvPr id="114" name="Text 112"/>
+          <p:cNvSpPr txBox="1"/>
+          <p:nvPr/>
+        </p:nvSpPr>
+        <p:spPr>
+          <a:xfrm>
+            <a:off x="10477500" y="4297680"/>
+            <a:ext cx="274320" cy="274320"/>
+          </a:xfrm>
+          <a:prstGeom prst="rect">
+            <a:avLst/>
+          </a:prstGeom>
+          <a:noFill/>
+          <a:ln/>
+        </p:spPr>
+        <p:txBody>
+          <a:bodyPr wrap="square" lIns="0" tIns="0" rIns="0" bIns="0" rtlCol="0" anchor="ctr"/>
+          <a:lstStyle/>
+          <a:p>
+            <a:pPr algn="ctr" indent="0" marL="0">
+              <a:buNone/>
+            </a:pPr>
+            <a:r>
+              <a:rPr lang="en-US" sz="800" b="1" dirty="0">
+                <a:solidFill>
+                  <a:srgbClr val="FFFFFF"/>
+                </a:solidFill>
+                <a:latin typeface="Calibri" pitchFamily="34" charset="0"/>
+                <a:ea typeface="Calibri" pitchFamily="34" charset="-122"/>
+                <a:cs typeface="Calibri" pitchFamily="34" charset="-120"/>
+              </a:rPr>
+              <a:t>+1</a:t>
+            </a:r>
+            <a:endParaRPr lang="en-US" sz="800" dirty="0"/>
+          </a:p>
+        </p:txBody>
+      </p:sp>
+      <p:sp>
+        <p:nvSpPr>
+          <p:cNvPr id="115" name="Shape 113"/>
+          <p:cNvSpPr/>
+          <p:nvPr/>
+        </p:nvSpPr>
+        <p:spPr>
+          <a:xfrm>
+            <a:off x="11282172" y="4297680"/>
+            <a:ext cx="274320" cy="274320"/>
+          </a:xfrm>
+          <a:prstGeom prst="ellipse">
+            <a:avLst/>
+          </a:prstGeom>
+          <a:solidFill>
+            <a:srgbClr val="6A9B6E"/>
+          </a:solidFill>
+          <a:ln w="12700">
+            <a:solidFill>
+              <a:srgbClr val="FFFFFF"/>
+            </a:solidFill>
+            <a:prstDash val="solid"/>
+          </a:ln>
+        </p:spPr>
+      </p:sp>
+      <p:sp>
+        <p:nvSpPr>
+          <p:cNvPr id="116" name="Text 114"/>
+          <p:cNvSpPr txBox="1"/>
+          <p:nvPr/>
+        </p:nvSpPr>
+        <p:spPr>
+          <a:xfrm>
+            <a:off x="11282172" y="4297680"/>
+            <a:ext cx="274320" cy="274320"/>
+          </a:xfrm>
+          <a:prstGeom prst="rect">
+            <a:avLst/>
+          </a:prstGeom>
+          <a:noFill/>
+          <a:ln/>
+        </p:spPr>
+        <p:txBody>
+          <a:bodyPr wrap="square" lIns="0" tIns="0" rIns="0" bIns="0" rtlCol="0" anchor="ctr"/>
+          <a:lstStyle/>
+          <a:p>
+            <a:pPr algn="ctr" indent="0" marL="0">
+              <a:buNone/>
+            </a:pPr>
+            <a:r>
+              <a:rPr lang="en-US" sz="800" b="1" dirty="0">
+                <a:solidFill>
+                  <a:srgbClr val="FFFFFF"/>
+                </a:solidFill>
+                <a:latin typeface="Calibri" pitchFamily="34" charset="0"/>
+                <a:ea typeface="Calibri" pitchFamily="34" charset="-122"/>
+                <a:cs typeface="Calibri" pitchFamily="34" charset="-120"/>
+              </a:rPr>
+              <a:t>+1</a:t>
+            </a:r>
+            <a:endParaRPr lang="en-US" sz="800" dirty="0"/>
+          </a:p>
+        </p:txBody>
+      </p:sp>
+      <p:sp>
+        <p:nvSpPr>
+          <p:cNvPr id="117" name="Text 115"/>
           <p:cNvSpPr txBox="1"/>
           <p:nvPr/>
         </p:nvSpPr>
@@ -27273,7 +27529,7 @@
                 <a:ea typeface="Calibri" pitchFamily="34" charset="-122"/>
                 <a:cs typeface="Calibri" pitchFamily="34" charset="-120"/>
               </a:rPr>
-              <a:t>Dos seniors, grado +1; cuatro plenos</a:t>
+              <a:t>Dos seniors, grado +2; cuatro plenos, grado +1</a:t>
             </a:r>
             <a:endParaRPr lang="en-US" sz="900" dirty="0"/>
           </a:p>
@@ -27281,7 +27537,7 @@
       </p:sp>
       <p:sp>
         <p:nvSpPr>
-          <p:cNvPr id="110" name="Text 108"/>
+          <p:cNvPr id="118" name="Text 116"/>
           <p:cNvSpPr txBox="1"/>
           <p:nvPr/>
         </p:nvSpPr>
@@ -27312,7 +27568,7 @@
                 <a:ea typeface="Calibri" pitchFamily="34" charset="-122"/>
                 <a:cs typeface="Calibri" pitchFamily="34" charset="-120"/>
               </a:rPr>
-              <a:t>Los seniors asumen los bloques críticos (Deudores y REDEC; datos, automatización y controles) y la validación; los plenos ejecutan bajo control dual con ruta a senior.</a:t>
+              <a:t>Todo el equipo sube un grado; los dos seniors suben dos, asumen los bloques críticos (Deudores y REDEC; datos, automatización y controles) y la validación. Los plenos ejecutan bajo control dual con ruta a senior.</a:t>
             </a:r>
             <a:endParaRPr lang="en-US" sz="950" dirty="0"/>
           </a:p>
@@ -27320,7 +27576,7 @@
       </p:sp>
       <p:sp>
         <p:nvSpPr>
-          <p:cNvPr id="111" name="Text 109"/>
+          <p:cNvPr id="119" name="Text 117"/>
           <p:cNvSpPr txBox="1"/>
           <p:nvPr/>
         </p:nvSpPr>

</xml_diff>